<commit_message>
Talk: Proposal_Team5_v2.pptx = same slides, script rewritten along the flow review; Proposal_Team5.pptx keeps the earlier script
Co-Authored-By: Claude Opus 5.5 (1M context) <noreply@anthropic.com>
</commit_message>
<xml_diff>
--- a/Proposal_Team5.pptx
+++ b/Proposal_Team5.pptx
@@ -142,7 +142,7 @@
   <p:extLst>
     <p:ext uri="{521415D9-36F7-43E2-AB2F-B90AF26B5E84}">
       <p14:sectionLst xmlns:p14="http://schemas.microsoft.com/office/powerpoint/2010/main">
-        <p14:section name="Talk" id="{b611fe70-d987-260b-ebc9-3081d79a73c6}">
+        <p14:section name="Talk" id="{4b98485c-2685-ccc7-7d46-845684e7c05d}">
           <p14:sldIdLst>
             <p14:sldId id="256"/>
             <p14:sldId id="257"/>
@@ -155,7 +155,7 @@
             <p14:sldId id="264"/>
           </p14:sldIdLst>
         </p14:section>
-        <p14:section name="Extra pages" id="{e5d303d5-df49-e37e-3e67-6b41d6a65282}">
+        <p14:section name="Extra pages" id="{64b7378b-f2a2-c5d3-84c9-2dcba15a4cde}">
           <p14:sldIdLst>
             <p14:sldId id="265"/>
             <p14:sldId id="266"/>
@@ -1410,7 +1410,7 @@
           <a:p>
             <a:r>
               <a:rPr lang="en-US" dirty="0"/>
-              <a:t>(15초) 안녕하세요, 5조입니다. 저희는 답을 정확히 계산해야 하는 수학 문제를 LLM이 프로그램을 짜서 푸는 경우에 집중합니다. 목표는 더 적은 토큰으로 맞는 답을 얻는 것입니다.</a:t>
+              <a:t>(10초) 안녕하세요, 5조입니다. 저희는 답을 정확히 계산해야 하는 수학 문제를 LLM이 프로그램을 짜서 푸는 경우에 집중합니다. 목표는 더 적은 토큰으로 맞는 답을 얻는 것입니다.</a:t>
             </a:r>
             <a:endParaRPr lang="en-US" dirty="0"/>
           </a:p>
@@ -2378,7 +2378,7 @@
           <a:p>
             <a:r>
               <a:rPr lang="en-US" dirty="0"/>
-              <a:t>(35초) 저희가 다루는 문제는 네 종류이고, 두 무리로 나뉩니다. 기하와 경시 문제는 맞는 알고리즘이 필요하고, 배송 경로와 최적화 문장제는 솔버 라이브러리를 맞게 부르는 법이 필요합니다. 이런 코드는 이미 코딩 에이전트가 실제로 쓰고 있는데, 틀려도 티가 나지 않고, 오래 생각하게 하면 비용이 큽니다. 답이 정확히 하나라서 코드로 채점할 수 있다는 점도 이 문제들을 고른 이유입니다. 이 두 무리를 기억해 주세요. 뒤에서 각각 다른 해결책이 필요합니다.</a:t>
+              <a:t>(25초) 저희가 푸는 문제는 네 종류입니다. 기하와 Codeforces 경시 문제는 맞는 알고리즘이, 배송 경로와 최적화 문장제는 솔버를 맞게 부르는 법이 필요합니다. 경시 문제의 중앙값은 Codeforces Master 수준입니다. 답이 정확히 하나라 코드로 채점할 수 있고, 필요한 것이 서로 달라서 추가 노력을 어디에 쓸지 비교하기 좋습니다.</a:t>
             </a:r>
             <a:endParaRPr lang="en-US" dirty="0"/>
           </a:p>
@@ -3346,7 +3346,7 @@
           <a:p>
             <a:r>
               <a:rPr lang="en-US" dirty="0"/>
-              <a:t>(10초) 먼저, 계산은 프로그램에 맡깁니다. 같은 도형을 옮기고 돌리면 말로 한 답은 매번 바뀌지만, 프로그램은 항상 436입니다. 그런데 프로그램에도 문제가 있습니다.</a:t>
+              <a:t>(15초) LLM은 말로 답할 수도, 프로그램을 짤 수도 있습니다. 같은 도형을 옮기고 돌리면 말로 한 답은 매번 바뀌지만, 프로그램은 항상 436입니다. 그래서 계산은 프로그램에 맡깁니다.</a:t>
             </a:r>
             <a:endParaRPr lang="en-US" dirty="0"/>
           </a:p>
@@ -4050,7 +4050,7 @@
           <a:p>
             <a:r>
               <a:rPr lang="en-US" dirty="0"/>
-              <a:t>(40초) 두 가지가 문제입니다. 첫째, 프로그램은 조용히 틀립니다. 점 10개를 감싸는 고무줄의 꼭짓점은 6개인데, 같은 모델에게 문제만 주면 6을 내고, 코딩 에이전트가 받는 도구 목록처럼 필요 없는 도우미 함수 8개를 같이 주면 0을 냅니다. 에러가 없어서 답을 모르면 틀린 줄 모릅니다. 없는 함수를 불러 멈추기도 합니다. 둘째, 오래 생각하면 비쌉니다. 큰 모델도 토큰을 4.4배 써서 9점을 더 얻을 뿐입니다. 그래서 질문은, 추가 노력을 힌트, 검사, 생각 중 어디에 써야 하느냐입니다.</a:t>
+              <a:t>(45초) 하지만 두 가지가 문제입니다. 첫째, 프로그램은 조용히 틀립니다. 왼쪽 그림처럼 점 10개를 고무줄로 감싸면 꼭짓점이 6개입니다. 같은 모델에게 이 개수를 세는 프로그램을 두 번 짜게 했습니다. 문제만 준 프로그램 A는 6을 내고, 필요 없는 도우미 함수 8개를 같이 준 프로그램 B는 0을 냅니다. B는 에러 없이 그냥 틀린 숫자를 내서, 답을 모르면 틀린 줄 알 수 없습니다. 없는 함수를 불러 아예 멈추기도 합니다. 둘째, 오래 생각하면 비쌉니다. gpt-oss-120b는 토큰을 4.4배 써서 9점을 더 얻습니다. 그래서 추가 노력을 힌트, 공짜 검사, 생각 중 어디에 쓸지가 저희 질문입니다.</a:t>
             </a:r>
             <a:endParaRPr lang="en-US" dirty="0"/>
           </a:p>
@@ -4138,7 +4138,7 @@
           <a:p>
             <a:r>
               <a:rPr lang="en-US" dirty="0"/>
-              <a:t>(35초) 첫 번째 발견은 솔버를 부르는 무리의 이야기입니다. 매뉴얼이 아니라 짧은 힌트를 주세요. 트럭 경로를 짜는 과제에 사용법 열한 줄을 붙이면, 모델이 맞는 함수를 불러 최적 경로를 찾습니다. 필요한 규칙이 빠진 긴 매뉴얼을 주면 없는 함수를 지어내 멈춥니다. 30문제에서 아무것도 안 주면 23%, 오래 생각하게 하면 오히려 3%, 짧은 힌트는 83%입니다. 모르는 함수 이름은 오래 생각한다고 생기지 않습니다. 그럼 알고리즘이 틀리는 경우는 어떻게 할까요?
+              <a:t>(30초) 첫 번째 발견입니다. 매뉴얼이 아니라 짧은 힌트를 주세요. 트럭 경로를 짜는 과제에 OR-Tools 사용법 열한 줄을 붙이면, Qwen3-32B가 맞는 함수를 불러 최적 경로를 찾습니다. 긴 참조 문서를 주면 없는 함수를 지어내 죽습니다. 30문제에서 아무것도 안 주면 23%, 오래 생각하면 3%, 짧은 힌트는 83%입니다. 이 힌트를 사람 없이 고르는 방법은 뒤의 방법 슬라이드에서 보여 드립니다.
 [참고, 읽지 않음] 모델은 답을 무작위로 뽑기 때문에 같은 실험도 돌릴 때마다 조금씩 다릅니다. 짧은 힌트 막대는 같은 실험을 세 번 돌린 평균입니다(77, 83, 90%). 나머지 막대는 한 번씩 돌린 결과입니다.</a:t>
             </a:r>
             <a:endParaRPr lang="en-US" dirty="0"/>
@@ -4227,7 +4227,7 @@
           <a:p>
             <a:r>
               <a:rPr lang="en-US" dirty="0"/>
-              <a:t>(45초) 두 번째 발견은 알고리즘이 필요한 무리의 이야기입니다. 생각은 공짜 검사가 실패한 문제에만 쓰세요. 공짜 검사란, 정답 없이 프로그램을 실행해서 이미 아는 것과 비교해 보는 것으로, 토큰이 거의 들지 않습니다. 경시 문제에는 막대가 3, 4, 5이면 답은 0이라는 예제가 있어서, 프로그램에 넣어 0이 나오면 그대로 내고, 다르면 그 문제만 더 생각합니다. 예제가 없으면 프로그램을 두 가지로 짜서 답이 다를 때만 생각합니다. 그러면 항상 오래 생각할 때와 같은 정확도를 토큰 18에서 27% 적게 얻고, 정답은 필요 없습니다. 이 둘을 합치면 저희 방법이 됩니다.
+              <a:t>(50초) 두 번째 발견입니다. 생각은 공짜 검사가 실패한 문제에만 쓰세요. 공짜 검사란, 정답 없이 프로그램을 실행해서 이미 아는 것과 비교해 보는 것으로, 토큰이 거의 들지 않습니다. 예를 들어 경시 문제에는 막대가 3, 4, 5이면 답은 0이라는 예제가 있습니다. 프로그램에 3, 4, 5를 넣어 0이 나오면 그대로 내고, 다르면 그 문제만 더 생각해서 다시 짭니다. 예제가 없으면 프로그램을 두 가지로 짜서, 6과 0처럼 답이 다를 때만 생각합니다. 결과는 오른쪽입니다. 경시 문제는 항상 오래 생각할 때와 같은 66%를 3만 대신 2만 5천 토큰에, 기하는 99%를 5.9k 대신 4.3k 토큰에 얻습니다. 정답은 필요 없습니다.
 [참고, 읽지 않음] 경시 66.3%는 예제와, 작은 입력을 전부 따져 보는 느린 프로그램, 두 검사를 함께 쓴 결과입니다. 예제만 쓰면 20k 토큰에 65.0%입니다.</a:t>
             </a:r>
             <a:endParaRPr lang="en-US" dirty="0"/>
@@ -4316,7 +4316,7 @@
           <a:p>
             <a:r>
               <a:rPr lang="en-US" dirty="0"/>
-              <a:t>(50초) 이제 4장의 질문에 답하면, 힌트를 먼저, 그다음 공짜 검사, 생각은 검사가 실패할 때만입니다. 위의 네 단계가 그 순서이고, 같은 종류가 다시 오면 검사된 프로그램을 재사용합니다. 힌트는 사람 없이 만듭니다. 같은 종류의 앞선 문제들에서 모델이 짠 프로그램 중 실행되어 숫자를 낸 것을 모으고, 가장 짧은 것을 예시로 붙입니다. 오른쪽처럼, 어려워 보이는 문제에 생각을 몰아주는 기존 방식은 74%, 검사만 써도 77%, 힌트까지 쓰면 84에서 87%이고 토큰도 적습니다. 핵심은, 문제가 어려워 보이는지가 아니라 무엇이 틀렸는지에 따라 노력을 쓰는 것입니다. 이름을 모르면 힌트, 조용히 틀리면 검사, 정말 어려우면 생각입니다.
+              <a:t>(65초) 둘을 합친 것이 저희 방법입니다. 위의 네 단계입니다. 힌트를 붙여 프로그램을 쓰고, 공짜 검사를 돌려서, 통과하면 내고 실패하면 그때만 생각합니다. 같은 종류가 다시 오면 그 프로그램을 재사용합니다. 아이콘은 각 단계를 쓰는 문제 종류입니다. 왼쪽은 힌트를 만드는 법입니다. 같은 종류의 앞선 문제들에서 모델이 짠 프로그램 중 실행되어 숫자를 낸 것을 모으고, 가장 짧은 것을 예시로 프롬프트에 붙입니다. 사람도 정답도 필요 없습니다. 실제 문제에서 힌트가 없으면 없는 함수를 불러 죽지만, 힌트가 있으면 두 버전이 모두 20000을 내서 바로 제출하고, 토큰은 생각만 할 때의 5.3k 대신 0.6k입니다. 오른쪽은 전체 결과입니다. 기하와 최적화 208문제를 세 모델로 풀면, 답이 갈리는 문제에 생각을 몰아주는 기존 방식은 74%, 검사가 실패할 때만 생각하면 77%, 여기에 검색한 힌트를 먼저 주면 84%, 사람이 쓴 힌트면 87%이고 토큰도 더 적습니다.
 [참고, 읽지 않음] 힌트 풀의 검사는 '실행되어 숫자를 냄'뿐이라, 풀 안에도 틀린 프로그램이 있습니다(8B 이상 모델에서 17~38%). 정답으로 나중에 확인해 보니, 실제로 고른 가장 짧은 프로그램은 8B 이상 다섯 모델 모두에서 맞았고, Qwen3-4B와 1.7B에서는 틀렸습니다.</a:t>
             </a:r>
             <a:endParaRPr lang="en-US" dirty="0"/>
@@ -4405,7 +4405,7 @@
           <a:p>
             <a:r>
               <a:rPr lang="en-US" dirty="0"/>
-              <a:t>(45초) 새로운 점은 세 가지입니다. 학습 없이 공짜 검사로 생각할 때를 정하고, 매뉴얼 대신 짧은 힌트를 사람 없이 고르며, 파인튜닝한 8B 특화 모델과 같은 정확도를 학습하지 않은 8B 모델로 냅니다. 앞으로 할 일도 세 가지입니다. 첫째, 처음 보는 문제 종류에서도 힌트를 자동으로 고르는 것. 둘째, 실행은 되지만 문제를 잘못 옮긴 프로그램까지 토큰 없이 잡는 검사. 셋째, Lean이 모든 단계를 검사해 주는 수학 증명으로 넓히는 것입니다. 각각 정확도와 토큰을 함께 재서 지금 결과와 비교하겠습니다. 정리하면, 짧은 힌트를 먼저 주고, 공짜 검사가 실패한 곳에서만 생각하게 하자는 것입니다.
+              <a:t>(50초) 새로운 점은 세 가지입니다. 학습 없이 공짜 검사가 실패할 때만 생각하면 74%가 77%가 되고, 매뉴얼 대신 짧은 힌트를 먼저 주면 87%가 되며, 그 힌트는 사람 없이 골라도 됩니다. 그리고 최적화 문장제 863개인 MAMO에서, 파인튜닝한 8B 특화 모델과 같은 69.5%를 같은 크기의 8B 모델로 학습 없이 냅니다. 다음은 세 가지입니다. 힌트를 문제 종류마다 자동으로 고르고, 토큰 없이 더 많이 잡는 검사를 만들고, 마지막으로 수학 증명으로 넓힙니다. 증명은 Lean이 모든 단계를 검사해 주니, 거기에 맞는 힌트를 찾는 것이 과제입니다. 정리하면, 짧은 힌트를 먼저 주고, 공짜 검사가 실패한 곳에서만 생각하게 하자는 것입니다.
 [더 자세히: 질문이 나오거나 시간이 남을 때]
 첫째 줄, 생각을 어디에 쓸지. 기존 방법은 어려워 보이는 문제에 계산을 더 쓰는 Snell 등의 방식과, 언제 생각할지를 강화학습으로 가르치는 Thinkless, AdaptThink입니다. 저희는 정답 없이 돌리는 공짜 검사가 실패한 문제에만 생각을 씁니다. 기하와 최적화 208문제를 세 모델로 풀면 74%가 87%로 오르고, 토큰은 문제당 4.1k에서 2.5k로 줄었습니다. 87%는 사람이 쓴 힌트를 쓴 결과이고, 검색으로 찾은 힌트로도 84%입니다.
 둘째 줄, 모델에게 무엇을 주는지. 기존에는 매뉴얼 전체를 주거나, 더 큰 교사 모델이 짜서 정답으로 확인한 프로그램 모음을 줍니다. 저희 힌트는 모델이 다른 문제에서 짜서 공짜 검사를 통과한 자기 프로그램입니다. 끝까지 남겨 둔 MAMO 벤치마크에서 사람이 쓴 힌트와 같은 79%를 냈습니다.
@@ -4498,7 +4498,7 @@
           <a:p>
             <a:r>
               <a:rPr lang="en-US" dirty="0"/>
-              <a:t>(10초) 감사합니다. 한 줄로 줄이면, 문제가 어려워 보이는지가 아니라 무엇이 틀렸는지에 따라 노력을 쓰자는 것입니다. 질문 받겠습니다.
+              <a:t>(5초) 감사합니다. 질문 받겠습니다.
 [발표자용] 예상 질문 → 보충 슬라이드 번호 (슬라이드 쇼에서 번호를 누르고 Enter):
 10: Why these problems? How do they differ? (slide 2)
 11: Do the findings cover every kind? (slide 2)

</xml_diff>